<commit_message>
Update presentation links and support reusable templates
</commit_message>
<xml_diff>
--- a/skill/source-backed-presentation/intake-pilot-example.pptx
+++ b/skill/source-backed-presentation/intake-pilot-example.pptx
@@ -471,12 +471,12 @@
           </a:p>
           <a:p xmlns:a="http://schemas.openxmlformats.org/drawingml/2006/main">
             <a:r>
-              <a:t>S0: https://github.com/SeungheonOh/awesome-dot/blob/main/skill/source-backed-presentation/source-packet.md#s0-brief</a:t>
+              <a:t>S0: https://github.com/SeungheonOh/dot-skills/blob/main/skill/source-backed-presentation/source-packet.md#s0-brief</a:t>
             </a:r>
           </a:p>
           <a:p xmlns:a="http://schemas.openxmlformats.org/drawingml/2006/main">
             <a:r>
-              <a:t>S3: https://github.com/SeungheonOh/awesome-dot/blob/main/skill/source-backed-presentation/source-packet.md#s3-extension-proposal</a:t>
+              <a:t>S3: https://github.com/SeungheonOh/dot-skills/blob/main/skill/source-backed-presentation/source-packet.md#s3-extension-proposal</a:t>
             </a:r>
           </a:p>
         </p:txBody>
@@ -571,12 +571,12 @@
           </a:p>
           <a:p xmlns:a="http://schemas.openxmlformats.org/drawingml/2006/main">
             <a:r>
-              <a:t>S1: https://github.com/SeungheonOh/awesome-dot/blob/main/skill/source-backed-presentation/source-packet.md#s1-measurement-notes</a:t>
+              <a:t>S1: https://github.com/SeungheonOh/dot-skills/blob/main/skill/source-backed-presentation/source-packet.md#s1-measurement-notes</a:t>
             </a:r>
           </a:p>
           <a:p xmlns:a="http://schemas.openxmlformats.org/drawingml/2006/main">
             <a:r>
-              <a:t>S2: https://github.com/SeungheonOh/awesome-dot/blob/main/skill/source-backed-presentation/source-packet.md#s2-interpretation-limits</a:t>
+              <a:t>S2: https://github.com/SeungheonOh/dot-skills/blob/main/skill/source-backed-presentation/source-packet.md#s2-interpretation-limits</a:t>
             </a:r>
           </a:p>
         </p:txBody>
@@ -671,12 +671,12 @@
           </a:p>
           <a:p xmlns:a="http://schemas.openxmlformats.org/drawingml/2006/main">
             <a:r>
-              <a:t>S1: https://github.com/SeungheonOh/awesome-dot/blob/main/skill/source-backed-presentation/source-packet.md#s1-measurement-notes</a:t>
+              <a:t>S1: https://github.com/SeungheonOh/dot-skills/blob/main/skill/source-backed-presentation/source-packet.md#s1-measurement-notes</a:t>
             </a:r>
           </a:p>
           <a:p xmlns:a="http://schemas.openxmlformats.org/drawingml/2006/main">
             <a:r>
-              <a:t>S2: https://github.com/SeungheonOh/awesome-dot/blob/main/skill/source-backed-presentation/source-packet.md#s2-interpretation-limits</a:t>
+              <a:t>S2: https://github.com/SeungheonOh/dot-skills/blob/main/skill/source-backed-presentation/source-packet.md#s2-interpretation-limits</a:t>
             </a:r>
           </a:p>
         </p:txBody>
@@ -771,12 +771,12 @@
           </a:p>
           <a:p xmlns:a="http://schemas.openxmlformats.org/drawingml/2006/main">
             <a:r>
-              <a:t>S2: https://github.com/SeungheonOh/awesome-dot/blob/main/skill/source-backed-presentation/source-packet.md#s2-interpretation-limits</a:t>
+              <a:t>S2: https://github.com/SeungheonOh/dot-skills/blob/main/skill/source-backed-presentation/source-packet.md#s2-interpretation-limits</a:t>
             </a:r>
           </a:p>
           <a:p xmlns:a="http://schemas.openxmlformats.org/drawingml/2006/main">
             <a:r>
-              <a:t>S3: https://github.com/SeungheonOh/awesome-dot/blob/main/skill/source-backed-presentation/source-packet.md#s3-extension-proposal</a:t>
+              <a:t>S3: https://github.com/SeungheonOh/dot-skills/blob/main/skill/source-backed-presentation/source-packet.md#s3-extension-proposal</a:t>
             </a:r>
           </a:p>
         </p:txBody>
@@ -871,12 +871,12 @@
           </a:p>
           <a:p xmlns:a="http://schemas.openxmlformats.org/drawingml/2006/main">
             <a:r>
-              <a:t>S0: https://github.com/SeungheonOh/awesome-dot/blob/main/skill/source-backed-presentation/source-packet.md#s0-brief</a:t>
+              <a:t>S0: https://github.com/SeungheonOh/dot-skills/blob/main/skill/source-backed-presentation/source-packet.md#s0-brief</a:t>
             </a:r>
           </a:p>
           <a:p xmlns:a="http://schemas.openxmlformats.org/drawingml/2006/main">
             <a:r>
-              <a:t>S4: https://github.com/SeungheonOh/awesome-dot/blob/main/skill/source-backed-presentation/source-packet.md#s4-proposed-review-rules</a:t>
+              <a:t>S4: https://github.com/SeungheonOh/dot-skills/blob/main/skill/source-backed-presentation/source-packet.md#s4-proposed-review-rules</a:t>
             </a:r>
           </a:p>
         </p:txBody>

</xml_diff>